<commit_message>
Re-render example explainer video without "no sign-up"
Co-Authored-By: Claude Opus 5.5 <noreply@anthropic.com>
Claude-Session: https://claude.ai/code/session_01StpPcB6m71huLjYc4mxQhr
</commit_message>
<xml_diff>
--- a/assets/example/explainer-deck.pptx
+++ b/assets/example/explainer-deck.pptx
@@ -716,7 +716,7 @@
           <a:lstStyle/>
           <a:p>
             <a:r>
-              <a:t>Everything runs in your browser. Nothing is uploaded, so your slides never leave your device. There is no sign-up and no watermark.</a:t>
+              <a:t>Everything runs in your browser. Nothing is uploaded, so your slides never leave your device. There is no watermark.</a:t>
             </a:r>
           </a:p>
         </p:txBody>
@@ -6259,7 +6259,7 @@
                 </a:solidFill>
                 <a:latin typeface="Inter"/>
               </a:rPr>
-              <a:t>No sign-up, no watermark</a:t>
+              <a:t>No watermark</a:t>
             </a:r>
           </a:p>
         </p:txBody>

</xml_diff>